<commit_message>
Define preço final do OCEO Portugal (setup 2.950 EUR + mensalidade 850 EUR/mês) e recalcula economia/projeções
Co-Authored-By: Claude Sonnet 5 <noreply@anthropic.com>
</commit_message>
<xml_diff>
--- a/outros-projetos/oceo/OCEO - Business Plan Europa (Portugal).pptx
+++ b/outros-projetos/oceo/OCEO - Business Plan Europa (Portugal).pptx
@@ -5421,7 +5421,7 @@
                 </a:solidFill>
                 <a:latin typeface="Arial"/>
               </a:rPr>
-              <a:t>19.359,84 €</a:t>
+              <a:t>19.104,07 €</a:t>
             </a:r>
           </a:p>
         </p:txBody>
@@ -5547,7 +5547,7 @@
                 </a:solidFill>
                 <a:latin typeface="Arial"/>
               </a:rPr>
-              <a:t>97,0%</a:t>
+              <a:t>95,7%</a:t>
             </a:r>
           </a:p>
         </p:txBody>
@@ -5673,7 +5673,7 @@
                 </a:solidFill>
                 <a:latin typeface="Arial"/>
               </a:rPr>
-              <a:t>≈ 3 DIAS</a:t>
+              <a:t>≈ 5 DIAS</a:t>
             </a:r>
           </a:p>
         </p:txBody>
@@ -5799,7 +5799,7 @@
                 </a:solidFill>
                 <a:latin typeface="Arial"/>
               </a:rPr>
-              <a:t>232.318 €</a:t>
+              <a:t>229.249 €</a:t>
             </a:r>
           </a:p>
         </p:txBody>
@@ -5877,7 +5877,7 @@
                 </a:solidFill>
                 <a:latin typeface="Arial"/>
               </a:rPr>
-              <a:t>* Usando "OCEO (ref.)" = conversão direta do preço brasileiro (594,23 €/mês) — não é o preço decidido pra Portugal. Ver próximo slide.</a:t>
+              <a:t>* Preço do OCEO em Portugal, decidido pelo Gilberto: 850 €/mês (mensalidade) + 2.950 € (setup, único). Ver próximo slide.</a:t>
             </a:r>
           </a:p>
         </p:txBody>
@@ -6203,7 +6203,7 @@
                 </a:solidFill>
                 <a:latin typeface="Arial"/>
               </a:rPr>
-              <a:t>Diferente do business plan brasileiro, aqui o preço final é decisão do Gilberto — este slide reúne os três números pra decidir.</a:t>
+              <a:t>O preço final em Portugal foi decidido pelo Gilberto: setup 2.950 € + mensalidade 850 €/mês. Este slide mostra onde essa decisão ficou entre o piso e o teto do mercado.</a:t>
             </a:r>
           </a:p>
         </p:txBody>
@@ -6696,7 +6696,7 @@
                 </a:solidFill>
                 <a:latin typeface="Arial"/>
               </a:rPr>
-              <a:t>A FAIXA</a:t>
+              <a:t>PREÇO DECIDIDO</a:t>
             </a:r>
           </a:p>
         </p:txBody>
@@ -6735,7 +6735,7 @@
                 </a:solidFill>
                 <a:latin typeface="Arial"/>
               </a:rPr>
-              <a:t>594 € – 19.954 €</a:t>
+              <a:t>850 €</a:t>
             </a:r>
           </a:p>
         </p:txBody>
@@ -6774,7 +6774,7 @@
                 </a:solidFill>
                 <a:latin typeface="Arial"/>
               </a:rPr>
-              <a:t>zona de decisão</a:t>
+              <a:t>por mês</a:t>
             </a:r>
           </a:p>
         </p:txBody>
@@ -6813,7 +6813,7 @@
                 </a:solidFill>
                 <a:latin typeface="Arial"/>
               </a:rPr>
-              <a:t>Considerar também: preço de concorrentes locais (slide Mercado), poder de compra português e o setup em EUR (referência: 2.122 €, mesma lógica de conversão).</a:t>
+              <a:t>Mais 2.950 € de setup (único). O preço fica a 95,7% de economia frente ao custo de montar a equipe (teto) e acima da conversão direta (piso) — margem pra cobrir a diferença de custo de vida português sem perder competitividade.</a:t>
             </a:r>
           </a:p>
         </p:txBody>
@@ -6898,7 +6898,7 @@
                 </a:solidFill>
                 <a:latin typeface="Arial"/>
               </a:rPr>
-              <a:t>Setup de referência: 2.122 € (conversão direta de R$ 12.500). Pensado pra PME acima de ~50.000 €/mês de faturamento — faixa a validar com o mercado português (ver Mercado, próximo slide).</a:t>
+              <a:t>Setup decidido: 2.950 € (acima da referência de conversão direta, 2.122 €). Pensado pra PME acima de ~50.000 €/mês de faturamento — faixa a validar com o mercado português (ver Mercado, próximo slide).</a:t>
             </a:r>
           </a:p>
         </p:txBody>
@@ -8489,7 +8489,7 @@
                 </a:solidFill>
                 <a:latin typeface="Arial"/>
               </a:rPr>
-              <a:t>1.452 clientes  ×  594 €/mês (preço de referência)  ×  12 meses de contrato</a:t>
+              <a:t>1.452 clientes  ×  850 €/mês (preço decidido)  ×  12 meses de contrato</a:t>
             </a:r>
           </a:p>
         </p:txBody>
@@ -8613,7 +8613,7 @@
                 </a:solidFill>
                 <a:latin typeface="Arial"/>
               </a:rPr>
-              <a:t>10.355.424 €</a:t>
+              <a:t>14.810.400 €</a:t>
             </a:r>
           </a:p>
         </p:txBody>
@@ -8739,7 +8739,7 @@
                 </a:solidFill>
                 <a:latin typeface="Arial"/>
               </a:rPr>
-              <a:t>3.081.463 €</a:t>
+              <a:t>4.283.400 €</a:t>
             </a:r>
           </a:p>
         </p:txBody>
@@ -8778,7 +8778,7 @@
                 </a:solidFill>
                 <a:latin typeface="Arial"/>
               </a:rPr>
-              <a:t>1.452 × 2.122 € (hipotético — ilustra o teto, não uma premissa de ritmo de vendas)</a:t>
+              <a:t>1.452 × 2.950 € (preço de setup decidido — ilustra potencial, não uma premissa de ritmo de vendas)</a:t>
             </a:r>
           </a:p>
         </p:txBody>
@@ -8863,7 +8863,7 @@
                 </a:solidFill>
                 <a:latin typeface="Arial"/>
               </a:rPr>
-              <a:t>⚠  Duas premissas empilhadas: 0,1% de participação NÃO é validado por funil comercial, e o preço usado é a conversão de referência (594 €), não o preço final decidido pra Portugal — mude o preço e este número muda.</a:t>
+              <a:t>⚠  Uma premissa em aberto: 0,1% de participação NÃO é validado por funil comercial — o preço usado (850 €/mês) já é o preço final decidido pra Portugal.</a:t>
             </a:r>
           </a:p>
         </p:txBody>
@@ -10241,7 +10241,7 @@
                 </a:solidFill>
                 <a:latin typeface="Arial"/>
               </a:rPr>
-              <a:t>Decidir o preço final em EUR — este documento dá o piso (594 €, conversão) e o teto (19.954 €, custo de equipe), a faixa é decisão do Gilberto.</a:t>
+              <a:t>Preço final em EUR decidido: setup 2.950 € + mensalidade 850 €/mês. Falta validar esse valor contra concorrência local e poder de compra português nos primeiros meses de venda.</a:t>
             </a:r>
           </a:p>
         </p:txBody>
@@ -11756,7 +11756,7 @@
                 </a:solidFill>
                 <a:latin typeface="Arial"/>
               </a:rPr>
-              <a:t>PREÇO EM DEFINIÇÃO</a:t>
+              <a:t>PREÇO DEFINIDO</a:t>
             </a:r>
           </a:p>
         </p:txBody>
@@ -11795,7 +11795,7 @@
                 </a:solidFill>
                 <a:latin typeface="Arial"/>
               </a:rPr>
-              <a:t>O preço do OCEO em EUR ainda não está fechado — este documento existe pra dar ao Gilberto o custo real de profissional em Portugal, base pra decidir o preço.</a:t>
+              <a:t>O preço do OCEO em EUR foi decidido pelo Gilberto: setup 2.950 € + mensalidade 850 €/mês. Este documento mantém o custo real de profissional em Portugal como base que sustentou a decisão.</a:t>
             </a:r>
           </a:p>
         </p:txBody>
@@ -12093,7 +12093,7 @@
                 </a:solidFill>
                 <a:latin typeface="Arial"/>
               </a:rPr>
-              <a:t>O preço brasileiro (setup R$ 12.500 + mensalidade R$ 3.500) convertido direto vira setup 2.122 € + mensalidade 594 €/mês — mas isso é só referência de câmbio, não o preço pra Portugal. O custo de mão de obra portuguesa é mais alto que o brasileiro em termos absolutos (ver Pilares GC–GI), então o preço final em EUR é decisão do Gilberto, não uma conversão automática.</a:t>
+              <a:t>O preço brasileiro (setup R$ 12.500 + mensalidade R$ 3.500) convertido direto vira setup 2.122 € + mensalidade 594 €/mês — essa é só a referência de câmbio, não o preço final. O custo de mão de obra portuguesa é mais alto que o brasileiro em termos absolutos (ver Pilares GC–GI), e o preço decidido pelo Gilberto para Portugal — setup 2.950 € + mensalidade 850 €/mês — reflete essa diferença, ficando acima da conversão direta.</a:t>
             </a:r>
           </a:p>
         </p:txBody>

</xml_diff>

<commit_message>
Remove referências ao preço antigo do OCEO Portugal e recalcula economia por pilar com o preço decidido (850 EUR/mês)
Co-Authored-By: Claude Sonnet 5 <noreply@anthropic.com>
</commit_message>
<xml_diff>
--- a/outros-projetos/oceo/OCEO - Business Plan Europa (Portugal).pptx
+++ b/outros-projetos/oceo/OCEO - Business Plan Europa (Portugal).pptx
@@ -6203,7 +6203,7 @@
                 </a:solidFill>
                 <a:latin typeface="Arial"/>
               </a:rPr>
-              <a:t>O preço final em Portugal foi decidido pelo Gilberto: setup 2.950 € + mensalidade 850 €/mês. Este slide mostra onde essa decisão ficou entre o piso e o teto do mercado.</a:t>
+              <a:t>O preço final em Portugal foi decidido pelo Gilberto: setup 2.950 € (único) + mensalidade 850 €/mês. Este slide mostra o preço decidido frente ao custo de montar a equipe internamente.</a:t>
             </a:r>
           </a:p>
         </p:txBody>
@@ -6290,7 +6290,7 @@
                 </a:solidFill>
                 <a:latin typeface="Arial"/>
               </a:rPr>
-              <a:t>PISO — CONVERSÃO DIRETA</a:t>
+              <a:t>SETUP (ÚNICO)</a:t>
             </a:r>
           </a:p>
         </p:txBody>
@@ -6329,7 +6329,7 @@
                 </a:solidFill>
                 <a:latin typeface="Arial"/>
               </a:rPr>
-              <a:t>594 €</a:t>
+              <a:t>2.950 €</a:t>
             </a:r>
           </a:p>
         </p:txBody>
@@ -6368,7 +6368,7 @@
                 </a:solidFill>
                 <a:latin typeface="Arial"/>
               </a:rPr>
-              <a:t>por mês</a:t>
+              <a:t>pagamento único</a:t>
             </a:r>
           </a:p>
         </p:txBody>
@@ -6407,7 +6407,7 @@
                 </a:solidFill>
                 <a:latin typeface="Arial"/>
               </a:rPr>
-              <a:t>R$ 3.500 convertido ao câmbio de agosto/2026 (1 EUR = 5,89 BRL). Não considera o custo de vida nem o poder de compra português — é só matemática de câmbio.</a:t>
+              <a:t>Cobre onboarding, configuração inicial e integração dos 5 pilares — cobrado uma única vez na contratação, não recorrente.</a:t>
             </a:r>
           </a:p>
         </p:txBody>
@@ -6696,7 +6696,7 @@
                 </a:solidFill>
                 <a:latin typeface="Arial"/>
               </a:rPr>
-              <a:t>PREÇO DECIDIDO</a:t>
+              <a:t>MENSALIDADE OCEO</a:t>
             </a:r>
           </a:p>
         </p:txBody>
@@ -6813,7 +6813,7 @@
                 </a:solidFill>
                 <a:latin typeface="Arial"/>
               </a:rPr>
-              <a:t>Mais 2.950 € de setup (único). O preço fica a 95,7% de economia frente ao custo de montar a equipe (teto) e acima da conversão direta (piso) — margem pra cobrir a diferença de custo de vida português sem perder competitividade.</a:t>
+              <a:t>95,7% de economia frente ao custo de montar a equipe internamente (card ao lado) — margem pra cobrir a diferença de custo de vida português sem perder competitividade.</a:t>
             </a:r>
           </a:p>
         </p:txBody>
@@ -6898,7 +6898,7 @@
                 </a:solidFill>
                 <a:latin typeface="Arial"/>
               </a:rPr>
-              <a:t>Setup decidido: 2.950 € (acima da referência de conversão direta, 2.122 €). Pensado pra PME acima de ~50.000 €/mês de faturamento — faixa a validar com o mercado português (ver Mercado, próximo slide).</a:t>
+              <a:t>Perfil de cliente em Portugal: PME a partir de 35.000 €/mês de faturamento — faixa a validar com o mercado português (ver Mercado, próximo slide).</a:t>
             </a:r>
           </a:p>
         </p:txBody>
@@ -12093,7 +12093,7 @@
                 </a:solidFill>
                 <a:latin typeface="Arial"/>
               </a:rPr>
-              <a:t>O preço brasileiro (setup R$ 12.500 + mensalidade R$ 3.500) convertido direto vira setup 2.122 € + mensalidade 594 €/mês — essa é só a referência de câmbio, não o preço final. O custo de mão de obra portuguesa é mais alto que o brasileiro em termos absolutos (ver Pilares GC–GI), e o preço decidido pelo Gilberto para Portugal — setup 2.950 € + mensalidade 850 €/mês — reflete essa diferença, ficando acima da conversão direta.</a:t>
+              <a:t>O custo de mão de obra portuguesa é mais alto que o brasileiro em termos absolutos (ver Pilares GC–GI). O preço decidido pelo Gilberto para Portugal — setup 2.950 € + mensalidade 850 €/mês — reflete essa diferença de custo de vida e mercado.</a:t>
             </a:r>
           </a:p>
         </p:txBody>
@@ -15660,7 +15660,7 @@
                 </a:solidFill>
                 <a:latin typeface="Arial"/>
               </a:rPr>
-              <a:t>6.758,79</a:t>
+              <a:t>6.503,02</a:t>
             </a:r>
           </a:p>
           <a:p>
@@ -15802,7 +15802,7 @@
                 </a:solidFill>
                 <a:latin typeface="Arial"/>
               </a:rPr>
-              <a:t>91,9%</a:t>
+              <a:t>88,4%</a:t>
             </a:r>
           </a:p>
         </p:txBody>
@@ -16646,7 +16646,7 @@
                 </a:solidFill>
                 <a:latin typeface="Arial"/>
               </a:rPr>
-              <a:t>⚠  Comparado a um Diretor Financeiro (2.689,71 €/mês em Portugal), a economia sobe para 77,9% — o pilar entrega leitura de nível diretoria.</a:t>
+              <a:t>⚠  Comparado a um Diretor Financeiro (2.689,71 €/mês em Portugal), a economia sobe para 68,4% — o pilar entrega leitura de nível diretoria.</a:t>
             </a:r>
           </a:p>
         </p:txBody>
@@ -16790,7 +16790,7 @@
                 </a:solidFill>
                 <a:latin typeface="Arial"/>
               </a:rPr>
-              <a:t>1.744,65</a:t>
+              <a:t>1.488,88</a:t>
             </a:r>
           </a:p>
           <a:p>
@@ -16932,7 +16932,7 @@
                 </a:solidFill>
                 <a:latin typeface="Arial"/>
               </a:rPr>
-              <a:t>74,6%</a:t>
+              <a:t>63,7%</a:t>
             </a:r>
           </a:p>
         </p:txBody>
@@ -17920,7 +17920,7 @@
                 </a:solidFill>
                 <a:latin typeface="Arial"/>
               </a:rPr>
-              <a:t>2.082,48</a:t>
+              <a:t>1.826,71</a:t>
             </a:r>
           </a:p>
           <a:p>
@@ -18062,7 +18062,7 @@
                 </a:solidFill>
                 <a:latin typeface="Arial"/>
               </a:rPr>
-              <a:t>77,8%</a:t>
+              <a:t>68,2%</a:t>
             </a:r>
           </a:p>
         </p:txBody>
@@ -19050,7 +19050,7 @@
                 </a:solidFill>
                 <a:latin typeface="Arial"/>
               </a:rPr>
-              <a:t>4.949,77</a:t>
+              <a:t>4.694,00</a:t>
             </a:r>
           </a:p>
           <a:p>
@@ -19192,7 +19192,7 @@
                 </a:solidFill>
                 <a:latin typeface="Arial"/>
               </a:rPr>
-              <a:t>89,3%</a:t>
+              <a:t>84,7%</a:t>
             </a:r>
           </a:p>
         </p:txBody>
@@ -20180,7 +20180,7 @@
                 </a:solidFill>
                 <a:latin typeface="Arial"/>
               </a:rPr>
-              <a:t>1.447,23</a:t>
+              <a:t>1.191,46</a:t>
             </a:r>
           </a:p>
           <a:p>
@@ -20322,7 +20322,7 @@
                 </a:solidFill>
                 <a:latin typeface="Arial"/>
               </a:rPr>
-              <a:t>70,9%</a:t>
+              <a:t>58,4%</a:t>
             </a:r>
           </a:p>
         </p:txBody>

</xml_diff>

<commit_message>
Corrige gráficos nativos do OCEO Portugal ainda com o preço antigo (594,23€)
Slides 5-9, 10 e 12 tinham gráficos de coluna com a série "OCEO (ref.)"
travada no valor de conversão direta antigo, não pego pela varredura de
texto anterior. Atualizado para 850€ (mensalidade decidida) em todos os 7.

Co-Authored-By: Claude Sonnet 5 <noreply@anthropic.com>
</commit_message>
<xml_diff>
--- a/outros-projetos/oceo/OCEO - Business Plan Europa (Portugal).pptx
+++ b/outros-projetos/oceo/OCEO - Business Plan Europa (Portugal).pptx
@@ -188,7 +188,7 @@
                   <c:v>7353.02</c:v>
                 </c:pt>
                 <c:pt idx="1">
-                  <c:v>594.23</c:v>
+                  <c:v>850</c:v>
                 </c:pt>
               </c:numCache>
             </c:numRef>
@@ -359,7 +359,7 @@
                   <c:v>2338.88</c:v>
                 </c:pt>
                 <c:pt idx="1">
-                  <c:v>594.23</c:v>
+                  <c:v>850</c:v>
                 </c:pt>
               </c:numCache>
             </c:numRef>
@@ -530,7 +530,7 @@
                   <c:v>2676.71</c:v>
                 </c:pt>
                 <c:pt idx="1">
-                  <c:v>594.23</c:v>
+                  <c:v>850</c:v>
                 </c:pt>
               </c:numCache>
             </c:numRef>
@@ -701,7 +701,7 @@
                   <c:v>5544.0</c:v>
                 </c:pt>
                 <c:pt idx="1">
-                  <c:v>594.23</c:v>
+                  <c:v>850</c:v>
                 </c:pt>
               </c:numCache>
             </c:numRef>
@@ -872,7 +872,7 @@
                   <c:v>2041.46</c:v>
                 </c:pt>
                 <c:pt idx="1">
-                  <c:v>594.23</c:v>
+                  <c:v>850</c:v>
                 </c:pt>
               </c:numCache>
             </c:numRef>
@@ -1043,7 +1043,7 @@
                   <c:v>19954.07</c:v>
                 </c:pt>
                 <c:pt idx="1">
-                  <c:v>594.23</c:v>
+                  <c:v>850</c:v>
                 </c:pt>
               </c:numCache>
             </c:numRef>
@@ -1214,7 +1214,7 @@
                   <c:v>20</c:v>
                 </c:pt>
                 <c:pt idx="1">
-                  <c:v>594.23</c:v>
+                  <c:v>850</c:v>
                 </c:pt>
               </c:numCache>
             </c:numRef>

</xml_diff>